<commit_message>
Fix YSZ stack description (BN crucible on alumina rod) and label Fig. 1 control-computer icon
The high-temperature compatibility survey misread the Key Takeaways
configuration diagrams: there is no BN-lined alumina crucible. Each stack
variant seats in a boron nitride crucible resting on the alumina support
rod (Ta/YSZ/BN/Alumina, Graphite(YSZ)/BN/Alumina, Ta/YSZ/Ta/BN/Alumina).

The unlabeled block in the top-left of Fig. 1 is a stock "Processor
outline" icon representing the control computer; it is now labeled
"Control Computer (LabVIEW + DAQ)" in the source PPTX and the caption.

Co-authored-by: Ronnie Guymon <244881888+ronnie-guymon@users.noreply.github.com>

Co-Authored-By: Claude Fable 5 <noreply@anthropic.com>
</commit_message>
<xml_diff>
--- a/docs/induction-furnace-schematic.pptx
+++ b/docs/induction-furnace-schematic.pptx
@@ -7673,6 +7673,37 @@
           <a:p>
             <a:pPr algn="ctr"/>
             <a:endParaRPr lang="en-US"/>
+          </a:p>
+        </p:txBody>
+      </p:sp>
+      <p:sp>
+        <p:nvSpPr>
+          <p:cNvPr id="137" name="TextBox 136"/>
+          <p:cNvSpPr txBox="1"/>
+          <p:nvPr/>
+        </p:nvSpPr>
+        <p:spPr>
+          <a:xfrm>
+            <a:off x="274320" y="2788920"/>
+            <a:ext cx="2286000" cy="822960"/>
+          </a:xfrm>
+          <a:prstGeom prst="rect">
+            <a:avLst/>
+          </a:prstGeom>
+          <a:noFill/>
+        </p:spPr>
+        <p:txBody>
+          <a:bodyPr wrap="square">
+            <a:spAutoFit/>
+          </a:bodyPr>
+          <a:lstStyle/>
+          <a:p>
+            <a:pPr algn="ctr"/>
+            <a:r>
+              <a:rPr sz="1800"/>
+              <a:t>Control Computer
+(LabVIEW + DAQ)</a:t>
+            </a:r>
           </a:p>
         </p:txBody>
       </p:sp>

</xml_diff>